<commit_message>
docs: add OPEN_AGENDA_SLUG to Changer d'Agenda slide and résultats slide
Updated slide 11 and slide 13 to include OPEN_AGENDA_SLUG env variable
alongside OPEN_AGENDA_UID in the configuration instructions.

Co-Authored-By: Claude Sonnet 4.6 <noreply@anthropic.com>
</commit_message>
<xml_diff>
--- a/pulsevents_soutenance.pptx
+++ b/pulsevents_soutenance.pptx
@@ -5369,7 +5369,7 @@
                 </a:solidFill>
                 <a:latin typeface="Calibri"/>
               </a:rPr>
-              <a:t>›  Périmètre configurable — TARGET_CITY + OPEN_AGENDA_UID dans .env + rebuild</a:t>
+              <a:t>›  Périmètre configurable — TARGET_CITY + OPEN_AGENDA_UID + OPEN_AGENDA_SLUG dans .env + rebuild</a:t>
             </a:r>
           </a:p>
           <a:p>
@@ -6445,7 +6445,26 @@
                 </a:solidFill>
                 <a:latin typeface="Consolas"/>
               </a:rPr>
-              <a:t>OPEN_AGENDA_UID=XXXXXXXX</a:t>
+              <a:t>OPEN_AGENDA_UID=XXXXXXXX  # UID numérique</a:t>
+            </a:r>
+          </a:p>
+          <a:p>
+            <a:pPr algn="l">
+              <a:spcBef>
+                <a:spcPts val="200"/>
+              </a:spcBef>
+              <a:spcAft>
+                <a:spcPts val="360"/>
+              </a:spcAft>
+            </a:pPr>
+            <a:r>
+              <a:rPr sz="900" b="0" i="0">
+                <a:solidFill>
+                  <a:srgbClr val="4D9EFF"/>
+                </a:solidFill>
+                <a:latin typeface="Consolas"/>
+              </a:rPr>
+              <a:t>OPEN_AGENDA_SLUG=nom-agenda  # slug texte</a:t>
             </a:r>
           </a:p>
           <a:p>

</xml_diff>